<commit_message>
Carousel PPTX v2: Canva-safe fonts, fix CTA slide spacing
</commit_message>
<xml_diff>
--- a/ads/2026-06/kynskyn-scalp-carousel.pptx
+++ b/ads/2026-06/kynskyn-scalp-carousel.pptx
@@ -3207,7 +3207,7 @@
                 <a:solidFill>
                   <a:srgbClr val="D4952A"/>
                 </a:solidFill>
-                <a:latin typeface="ABC Maxi Sharp"/>
+                <a:latin typeface="Montserrat"/>
               </a:rPr>
               <a:t>THE SCALP EDITION</a:t>
             </a:r>
@@ -3246,7 +3246,7 @@
                 <a:solidFill>
                   <a:srgbClr val="FFF4CE"/>
                 </a:solidFill>
-                <a:latin typeface="STK Bureau Serif"/>
+                <a:latin typeface="Georgia"/>
               </a:rPr>
               <a:t>It looks like dandruff.</a:t>
             </a:r>
@@ -3256,7 +3256,7 @@
                 <a:solidFill>
                   <a:srgbClr val="FFF4CE"/>
                 </a:solidFill>
-                <a:latin typeface="STK Bureau Serif"/>
+                <a:latin typeface="Georgia"/>
               </a:rPr>
               <a:t/>
             </a:r>
@@ -3265,7 +3265,7 @@
                 <a:solidFill>
                   <a:srgbClr val="F8B044"/>
                 </a:solidFill>
-                <a:latin typeface="STK Bureau Serif"/>
+                <a:latin typeface="Georgia"/>
               </a:rPr>
               <a:t>It often isn't.</a:t>
             </a:r>
@@ -3304,7 +3304,7 @@
                 <a:solidFill>
                   <a:srgbClr val="DAE3E7"/>
                 </a:solidFill>
-                <a:latin typeface="STK Bureau Sans"/>
+                <a:latin typeface="Open Sans"/>
               </a:rPr>
               <a:t>Why scalp flaking keeps coming back, and what finally treats it.</a:t>
             </a:r>
@@ -3367,7 +3367,7 @@
                 <a:solidFill>
                   <a:srgbClr val="D4952A"/>
                 </a:solidFill>
-                <a:latin typeface="ABC Maxi Sharp"/>
+                <a:latin typeface="Montserrat"/>
               </a:rPr>
               <a:t>01 / 08</a:t>
             </a:r>
@@ -3406,7 +3406,7 @@
                 <a:solidFill>
                   <a:srgbClr val="DAE3E7"/>
                 </a:solidFill>
-                <a:latin typeface="STK Bureau Sans"/>
+                <a:latin typeface="Open Sans"/>
               </a:rPr>
               <a:t>swipe</a:t>
             </a:r>
@@ -3580,7 +3580,7 @@
                 <a:solidFill>
                   <a:srgbClr val="FFF4CE"/>
                 </a:solidFill>
-                <a:latin typeface="ABC Maxi Sharp"/>
+                <a:latin typeface="Montserrat"/>
               </a:rPr>
               <a:t>02 / 08</a:t>
             </a:r>
@@ -3619,7 +3619,7 @@
                 <a:solidFill>
                   <a:srgbClr val="F8B044"/>
                 </a:solidFill>
-                <a:latin typeface="ABC Maxi Sharp"/>
+                <a:latin typeface="Montserrat"/>
               </a:rPr>
               <a:t>THE CYCLE</a:t>
             </a:r>
@@ -3658,7 +3658,7 @@
                 <a:solidFill>
                   <a:srgbClr val="FFF4CE"/>
                 </a:solidFill>
-                <a:latin typeface="STK Bureau Serif"/>
+                <a:latin typeface="Georgia"/>
               </a:rPr>
               <a:t>The two-week</a:t>
             </a:r>
@@ -3668,7 +3668,7 @@
                 <a:solidFill>
                   <a:srgbClr val="FFF4CE"/>
                 </a:solidFill>
-                <a:latin typeface="STK Bureau Serif"/>
+                <a:latin typeface="Georgia"/>
               </a:rPr>
               <a:t>shampoo cycle</a:t>
             </a:r>
@@ -3707,7 +3707,7 @@
                 <a:solidFill>
                   <a:srgbClr val="DAE3E7"/>
                 </a:solidFill>
-                <a:latin typeface="STK Bureau Sans"/>
+                <a:latin typeface="Open Sans"/>
               </a:rPr>
               <a:t>A new shampoo helps for two weeks. Then the flakes come back, along with the itch. Dark shirts get retired. The cycle repeats for years.</a:t>
             </a:r>
@@ -3837,7 +3837,7 @@
                 <a:solidFill>
                   <a:srgbClr val="FFF4CE"/>
                 </a:solidFill>
-                <a:latin typeface="ABC Maxi Sharp"/>
+                <a:latin typeface="Montserrat"/>
               </a:rPr>
               <a:t>03 / 08</a:t>
             </a:r>
@@ -3876,7 +3876,7 @@
                 <a:solidFill>
                   <a:srgbClr val="C5DE55"/>
                 </a:solidFill>
-                <a:latin typeface="ABC Maxi Sharp"/>
+                <a:latin typeface="Montserrat"/>
               </a:rPr>
               <a:t>THE CAUSE</a:t>
             </a:r>
@@ -3915,7 +3915,7 @@
                 <a:solidFill>
                   <a:srgbClr val="FFF4CE"/>
                 </a:solidFill>
-                <a:latin typeface="STK Bureau Serif"/>
+                <a:latin typeface="Georgia"/>
               </a:rPr>
               <a:t>Recurring flakes usually have a name: seborrheic dermatitis</a:t>
             </a:r>
@@ -3954,7 +3954,7 @@
                 <a:solidFill>
                   <a:srgbClr val="EBE7C0"/>
                 </a:solidFill>
-                <a:latin typeface="STK Bureau Sans"/>
+                <a:latin typeface="Open Sans"/>
               </a:rPr>
               <a:t>It's tied to Malassezia, a yeast that lives on nearly every scalp. Some skin reacts to it with flaking and itch. That reaction is medical, and the shampoo aisle was never built to treat it.</a:t>
             </a:r>
@@ -4067,7 +4067,7 @@
                 <a:solidFill>
                   <a:srgbClr val="641220"/>
                 </a:solidFill>
-                <a:latin typeface="ABC Maxi Sharp"/>
+                <a:latin typeface="Montserrat"/>
               </a:rPr>
               <a:t>04 / 08</a:t>
             </a:r>
@@ -4106,7 +4106,7 @@
                 <a:solidFill>
                   <a:srgbClr val="C54427"/>
                 </a:solidFill>
-                <a:latin typeface="ABC Maxi Sharp"/>
+                <a:latin typeface="Montserrat"/>
               </a:rPr>
               <a:t>THE WAIT</a:t>
             </a:r>
@@ -4145,7 +4145,7 @@
                 <a:solidFill>
                   <a:srgbClr val="641220"/>
                 </a:solidFill>
-                <a:latin typeface="STK Bureau Serif"/>
+                <a:latin typeface="Georgia"/>
               </a:rPr>
               <a:t>3.6</a:t>
             </a:r>
@@ -4184,7 +4184,7 @@
                 <a:solidFill>
                   <a:srgbClr val="C54427"/>
                 </a:solidFill>
-                <a:latin typeface="STK Bureau Serif"/>
+                <a:latin typeface="Georgia"/>
               </a:rPr>
               <a:t>years</a:t>
             </a:r>
@@ -4223,7 +4223,7 @@
                 <a:solidFill>
                   <a:srgbClr val="2A0208"/>
                 </a:solidFill>
-                <a:latin typeface="STK Bureau Sans"/>
+                <a:latin typeface="Open Sans"/>
               </a:rPr>
               <a:t>The average time spent chasing a wrong diagnosis for a chronic skin condition. Flaking gets written off as dryness or product buildup while the actual cause goes untreated.</a:t>
             </a:r>
@@ -4312,7 +4312,7 @@
                 <a:solidFill>
                   <a:srgbClr val="C5FEFF"/>
                 </a:solidFill>
-                <a:latin typeface="ABC Maxi Sharp"/>
+                <a:latin typeface="Montserrat"/>
               </a:rPr>
               <a:t>05 / 08</a:t>
             </a:r>
@@ -4351,7 +4351,7 @@
                 <a:solidFill>
                   <a:srgbClr val="C5FEFF"/>
                 </a:solidFill>
-                <a:latin typeface="ABC Maxi Sharp"/>
+                <a:latin typeface="Montserrat"/>
               </a:rPr>
               <a:t>THE DIFFERENCE</a:t>
             </a:r>
@@ -4390,7 +4390,7 @@
                 <a:solidFill>
                   <a:srgbClr val="FFF4CE"/>
                 </a:solidFill>
-                <a:latin typeface="STK Bureau Serif"/>
+                <a:latin typeface="Georgia"/>
               </a:rPr>
               <a:t>Washing flakes away isn't the same as treating them</a:t>
             </a:r>
@@ -4475,7 +4475,7 @@
                 <a:solidFill>
                   <a:srgbClr val="C54427"/>
                 </a:solidFill>
-                <a:latin typeface="ABC Maxi Sharp"/>
+                <a:latin typeface="Montserrat"/>
               </a:rPr>
               <a:t>THE SHAMPOO AISLE</a:t>
             </a:r>
@@ -4514,7 +4514,7 @@
                 <a:solidFill>
                   <a:srgbClr val="2A0208"/>
                 </a:solidFill>
-                <a:latin typeface="STK Bureau Sans"/>
+                <a:latin typeface="Open Sans"/>
               </a:rPr>
               <a:t>Lifts flakes off the surface. The yeast underneath stays.</a:t>
             </a:r>
@@ -4599,7 +4599,7 @@
                 <a:solidFill>
                   <a:srgbClr val="F8B044"/>
                 </a:solidFill>
-                <a:latin typeface="ABC Maxi Sharp"/>
+                <a:latin typeface="Montserrat"/>
               </a:rPr>
               <a:t>PRESCRIPTION CARE</a:t>
             </a:r>
@@ -4638,7 +4638,7 @@
                 <a:solidFill>
                   <a:srgbClr val="FFF4CE"/>
                 </a:solidFill>
-                <a:latin typeface="STK Bureau Sans"/>
+                <a:latin typeface="Open Sans"/>
               </a:rPr>
               <a:t>Targets the yeast and calms the inflammation it triggers.</a:t>
             </a:r>
@@ -4768,7 +4768,7 @@
                 <a:solidFill>
                   <a:srgbClr val="FFF4CE"/>
                 </a:solidFill>
-                <a:latin typeface="ABC Maxi Sharp"/>
+                <a:latin typeface="Montserrat"/>
               </a:rPr>
               <a:t>06 / 08</a:t>
             </a:r>
@@ -4853,7 +4853,7 @@
                 <a:solidFill>
                   <a:srgbClr val="C54427"/>
                 </a:solidFill>
-                <a:latin typeface="ABC Maxi Sharp"/>
+                <a:latin typeface="Montserrat"/>
               </a:rPr>
               <a:t>OFTEN MISSED</a:t>
             </a:r>
@@ -4892,7 +4892,7 @@
                 <a:solidFill>
                   <a:srgbClr val="2A0208"/>
                 </a:solidFill>
-                <a:latin typeface="STK Bureau Serif"/>
+                <a:latin typeface="Georgia"/>
               </a:rPr>
               <a:t>On darker skin, it rarely looks like the textbook photos</a:t>
             </a:r>
@@ -4931,7 +4931,7 @@
                 <a:solidFill>
                   <a:srgbClr val="2A0208"/>
                 </a:solidFill>
-                <a:latin typeface="STK Bureau Sans"/>
+                <a:latin typeface="Open Sans"/>
               </a:rPr>
               <a:t>Flaking can show up as lighter patches, ring-shaped spots, or irritation along the hairline. On deeper skin tones these signs get misread more often. Care should know what to look for.</a:t>
             </a:r>
@@ -5020,7 +5020,7 @@
                 <a:solidFill>
                   <a:srgbClr val="F8B044"/>
                 </a:solidFill>
-                <a:latin typeface="ABC Maxi Sharp"/>
+                <a:latin typeface="Montserrat"/>
               </a:rPr>
               <a:t>SAVE THIS</a:t>
             </a:r>
@@ -5059,7 +5059,7 @@
                 <a:solidFill>
                   <a:srgbClr val="FFF4CE"/>
                 </a:solidFill>
-                <a:latin typeface="STK Bureau Serif"/>
+                <a:latin typeface="Georgia"/>
               </a:rPr>
               <a:t>The short version</a:t>
             </a:r>
@@ -5142,7 +5142,7 @@
                 <a:solidFill>
                   <a:srgbClr val="D4952A"/>
                 </a:solidFill>
-                <a:latin typeface="ABC Maxi Sharp"/>
+                <a:latin typeface="Montserrat"/>
               </a:rPr>
               <a:t>1</a:t>
             </a:r>
@@ -5181,7 +5181,7 @@
                 <a:solidFill>
                   <a:srgbClr val="FFF4CE"/>
                 </a:solidFill>
-                <a:latin typeface="STK Bureau Sans"/>
+                <a:latin typeface="Open Sans"/>
               </a:rPr>
               <a:t>Flakes that keep coming back are usually a yeast reaction, not dryness.</a:t>
             </a:r>
@@ -5264,7 +5264,7 @@
                 <a:solidFill>
                   <a:srgbClr val="D4952A"/>
                 </a:solidFill>
-                <a:latin typeface="ABC Maxi Sharp"/>
+                <a:latin typeface="Montserrat"/>
               </a:rPr>
               <a:t>2</a:t>
             </a:r>
@@ -5303,7 +5303,7 @@
                 <a:solidFill>
                   <a:srgbClr val="FFF4CE"/>
                 </a:solidFill>
-                <a:latin typeface="STK Bureau Sans"/>
+                <a:latin typeface="Open Sans"/>
               </a:rPr>
               <a:t>Shampoo manages the symptom. Treatment addresses the cause.</a:t>
             </a:r>
@@ -5386,7 +5386,7 @@
                 <a:solidFill>
                   <a:srgbClr val="D4952A"/>
                 </a:solidFill>
-                <a:latin typeface="ABC Maxi Sharp"/>
+                <a:latin typeface="Montserrat"/>
               </a:rPr>
               <a:t>3</a:t>
             </a:r>
@@ -5425,7 +5425,7 @@
                 <a:solidFill>
                   <a:srgbClr val="FFF4CE"/>
                 </a:solidFill>
-                <a:latin typeface="STK Bureau Sans"/>
+                <a:latin typeface="Open Sans"/>
               </a:rPr>
               <a:t>Darker skin shows different signs, and they get missed more often.</a:t>
             </a:r>
@@ -5508,7 +5508,7 @@
                 <a:solidFill>
                   <a:srgbClr val="D4952A"/>
                 </a:solidFill>
-                <a:latin typeface="ABC Maxi Sharp"/>
+                <a:latin typeface="Montserrat"/>
               </a:rPr>
               <a:t>4</a:t>
             </a:r>
@@ -5547,7 +5547,7 @@
                 <a:solidFill>
                   <a:srgbClr val="FFF4CE"/>
                 </a:solidFill>
-                <a:latin typeface="STK Bureau Sans"/>
+                <a:latin typeface="Open Sans"/>
               </a:rPr>
               <a:t>A provider can tell the difference from clear photos and history.</a:t>
             </a:r>
@@ -5610,7 +5610,7 @@
                 <a:solidFill>
                   <a:srgbClr val="D0B09A"/>
                 </a:solidFill>
-                <a:latin typeface="ABC Maxi Sharp"/>
+                <a:latin typeface="Montserrat"/>
               </a:rPr>
               <a:t>07 / 08</a:t>
             </a:r>
@@ -5715,7 +5715,7 @@
                 <a:solidFill>
                   <a:srgbClr val="FFF4CE"/>
                 </a:solidFill>
-                <a:latin typeface="ABC Maxi Sharp"/>
+                <a:latin typeface="Montserrat"/>
               </a:rPr>
               <a:t>08 / 08</a:t>
             </a:r>
@@ -5754,7 +5754,7 @@
                 <a:solidFill>
                   <a:srgbClr val="C54427"/>
                 </a:solidFill>
-                <a:latin typeface="ABC Maxi Sharp"/>
+                <a:latin typeface="Montserrat"/>
               </a:rPr>
               <a:t>START HERE</a:t>
             </a:r>
@@ -5769,8 +5769,8 @@
         </p:nvSpPr>
         <p:spPr>
           <a:xfrm>
-            <a:off x="857250" y="1428750"/>
-            <a:ext cx="4953000" cy="3238500"/>
+            <a:off x="857250" y="1381125"/>
+            <a:ext cx="5048250" cy="2809875"/>
           </a:xfrm>
           <a:prstGeom prst="rect">
             <a:avLst/>
@@ -5789,11 +5789,11 @@
               </a:lnSpc>
             </a:pPr>
             <a:r>
-              <a:rPr sz="5400" b="0">
+              <a:rPr sz="4650" b="0">
                 <a:solidFill>
                   <a:srgbClr val="2A0208"/>
                 </a:solidFill>
-                <a:latin typeface="STK Bureau Serif"/>
+                <a:latin typeface="Georgia"/>
               </a:rPr>
               <a:t>Scalp care, reviewed by a licensed provider</a:t>
             </a:r>
@@ -5808,8 +5808,8 @@
         </p:nvSpPr>
         <p:spPr>
           <a:xfrm>
-            <a:off x="857250" y="4819650"/>
-            <a:ext cx="4953000" cy="2667000"/>
+            <a:off x="857250" y="4381500"/>
+            <a:ext cx="5048250" cy="2857500"/>
           </a:xfrm>
           <a:prstGeom prst="rect">
             <a:avLst/>
@@ -5824,15 +5824,15 @@
           <a:p>
             <a:pPr algn="l">
               <a:lnSpc>
-                <a:spcPct val="150000"/>
+                <a:spcPct val="145000"/>
               </a:lnSpc>
             </a:pPr>
             <a:r>
-              <a:rPr sz="2625" b="0">
+              <a:rPr sz="2400" b="0">
                 <a:solidFill>
                   <a:srgbClr val="2A0208"/>
                 </a:solidFill>
-                <a:latin typeface="STK Bureau Sans"/>
+                <a:latin typeface="Open Sans"/>
               </a:rPr>
               <a:t>Kyn Skyn connects patients with licensed providers who review photos and history online, then build a treatment plan. No waiting room.</a:t>
             </a:r>
@@ -5941,7 +5941,7 @@
                 <a:solidFill>
                   <a:srgbClr val="D4952A"/>
                 </a:solidFill>
-                <a:latin typeface="ABC Maxi Sharp"/>
+                <a:latin typeface="Montserrat"/>
               </a:rPr>
               <a:t>MONTHLY CARE PLAN</a:t>
             </a:r>
@@ -5980,7 +5980,7 @@
                 <a:solidFill>
                   <a:srgbClr val="F8B044"/>
                 </a:solidFill>
-                <a:latin typeface="STK Bureau Serif"/>
+                <a:latin typeface="Georgia"/>
               </a:rPr>
               <a:t>$29.99</a:t>
             </a:r>
@@ -6019,7 +6019,7 @@
                 <a:solidFill>
                   <a:srgbClr val="FFF4CE"/>
                 </a:solidFill>
-                <a:latin typeface="STK Bureau Sans"/>
+                <a:latin typeface="Open Sans"/>
               </a:rPr>
               <a:t>/ month</a:t>
             </a:r>
@@ -6058,7 +6058,7 @@
                 <a:solidFill>
                   <a:srgbClr val="F2E2C0"/>
                 </a:solidFill>
-                <a:latin typeface="STK Bureau Sans"/>
+                <a:latin typeface="Open Sans"/>
               </a:rPr>
               <a:t>Provider review and treatment plan included. Check‑ins after.</a:t>
             </a:r>
@@ -6113,7 +6113,7 @@
                 <a:solidFill>
                   <a:srgbClr val="2A0208"/>
                 </a:solidFill>
-                <a:latin typeface="STK Bureau Sans"/>
+                <a:latin typeface="Open Sans"/>
               </a:rPr>
               <a:t>Get a Kynsultation</a:t>
             </a:r>
@@ -6152,7 +6152,7 @@
                 <a:solidFill>
                   <a:srgbClr val="D4952A"/>
                 </a:solidFill>
-                <a:latin typeface="STK Bureau Sans"/>
+                <a:latin typeface="Open Sans"/>
               </a:rPr>
               <a:t>kynskyn.com</a:t>
             </a:r>

</xml_diff>

<commit_message>
Carousel PPTX v3: real brand font names for Canva brand-font matching
</commit_message>
<xml_diff>
--- a/ads/2026-06/kynskyn-scalp-carousel.pptx
+++ b/ads/2026-06/kynskyn-scalp-carousel.pptx
@@ -3207,7 +3207,7 @@
                 <a:solidFill>
                   <a:srgbClr val="D4952A"/>
                 </a:solidFill>
-                <a:latin typeface="Montserrat"/>
+                <a:latin typeface="ABC Maxi Sharp"/>
               </a:rPr>
               <a:t>THE SCALP EDITION</a:t>
             </a:r>
@@ -3246,7 +3246,7 @@
                 <a:solidFill>
                   <a:srgbClr val="FFF4CE"/>
                 </a:solidFill>
-                <a:latin typeface="Georgia"/>
+                <a:latin typeface="STK Bureau Serif Light"/>
               </a:rPr>
               <a:t>It looks like dandruff.</a:t>
             </a:r>
@@ -3256,7 +3256,7 @@
                 <a:solidFill>
                   <a:srgbClr val="FFF4CE"/>
                 </a:solidFill>
-                <a:latin typeface="Georgia"/>
+                <a:latin typeface="STK Bureau Serif Light"/>
               </a:rPr>
               <a:t/>
             </a:r>
@@ -3265,7 +3265,7 @@
                 <a:solidFill>
                   <a:srgbClr val="F8B044"/>
                 </a:solidFill>
-                <a:latin typeface="Georgia"/>
+                <a:latin typeface="STK Bureau Serif Light"/>
               </a:rPr>
               <a:t>It often isn't.</a:t>
             </a:r>
@@ -3304,7 +3304,7 @@
                 <a:solidFill>
                   <a:srgbClr val="DAE3E7"/>
                 </a:solidFill>
-                <a:latin typeface="Open Sans"/>
+                <a:latin typeface="STK Bureau Sans Book"/>
               </a:rPr>
               <a:t>Why scalp flaking keeps coming back, and what finally treats it.</a:t>
             </a:r>
@@ -3367,7 +3367,7 @@
                 <a:solidFill>
                   <a:srgbClr val="D4952A"/>
                 </a:solidFill>
-                <a:latin typeface="Montserrat"/>
+                <a:latin typeface="ABC Maxi Sharp"/>
               </a:rPr>
               <a:t>01 / 08</a:t>
             </a:r>
@@ -3406,7 +3406,7 @@
                 <a:solidFill>
                   <a:srgbClr val="DAE3E7"/>
                 </a:solidFill>
-                <a:latin typeface="Open Sans"/>
+                <a:latin typeface="STK Bureau Sans Book"/>
               </a:rPr>
               <a:t>swipe</a:t>
             </a:r>
@@ -3580,7 +3580,7 @@
                 <a:solidFill>
                   <a:srgbClr val="FFF4CE"/>
                 </a:solidFill>
-                <a:latin typeface="Montserrat"/>
+                <a:latin typeface="ABC Maxi Sharp"/>
               </a:rPr>
               <a:t>02 / 08</a:t>
             </a:r>
@@ -3619,7 +3619,7 @@
                 <a:solidFill>
                   <a:srgbClr val="F8B044"/>
                 </a:solidFill>
-                <a:latin typeface="Montserrat"/>
+                <a:latin typeface="ABC Maxi Sharp"/>
               </a:rPr>
               <a:t>THE CYCLE</a:t>
             </a:r>
@@ -3658,7 +3658,7 @@
                 <a:solidFill>
                   <a:srgbClr val="FFF4CE"/>
                 </a:solidFill>
-                <a:latin typeface="Georgia"/>
+                <a:latin typeface="STK Bureau Serif Light"/>
               </a:rPr>
               <a:t>The two-week</a:t>
             </a:r>
@@ -3668,7 +3668,7 @@
                 <a:solidFill>
                   <a:srgbClr val="FFF4CE"/>
                 </a:solidFill>
-                <a:latin typeface="Georgia"/>
+                <a:latin typeface="STK Bureau Serif Light"/>
               </a:rPr>
               <a:t>shampoo cycle</a:t>
             </a:r>
@@ -3707,7 +3707,7 @@
                 <a:solidFill>
                   <a:srgbClr val="DAE3E7"/>
                 </a:solidFill>
-                <a:latin typeface="Open Sans"/>
+                <a:latin typeface="STK Bureau Sans Book"/>
               </a:rPr>
               <a:t>A new shampoo helps for two weeks. Then the flakes come back, along with the itch. Dark shirts get retired. The cycle repeats for years.</a:t>
             </a:r>
@@ -3837,7 +3837,7 @@
                 <a:solidFill>
                   <a:srgbClr val="FFF4CE"/>
                 </a:solidFill>
-                <a:latin typeface="Montserrat"/>
+                <a:latin typeface="ABC Maxi Sharp"/>
               </a:rPr>
               <a:t>03 / 08</a:t>
             </a:r>
@@ -3876,7 +3876,7 @@
                 <a:solidFill>
                   <a:srgbClr val="C5DE55"/>
                 </a:solidFill>
-                <a:latin typeface="Montserrat"/>
+                <a:latin typeface="ABC Maxi Sharp"/>
               </a:rPr>
               <a:t>THE CAUSE</a:t>
             </a:r>
@@ -3915,7 +3915,7 @@
                 <a:solidFill>
                   <a:srgbClr val="FFF4CE"/>
                 </a:solidFill>
-                <a:latin typeface="Georgia"/>
+                <a:latin typeface="STK Bureau Serif Light"/>
               </a:rPr>
               <a:t>Recurring flakes usually have a name: seborrheic dermatitis</a:t>
             </a:r>
@@ -3954,7 +3954,7 @@
                 <a:solidFill>
                   <a:srgbClr val="EBE7C0"/>
                 </a:solidFill>
-                <a:latin typeface="Open Sans"/>
+                <a:latin typeface="STK Bureau Sans Book"/>
               </a:rPr>
               <a:t>It's tied to Malassezia, a yeast that lives on nearly every scalp. Some skin reacts to it with flaking and itch. That reaction is medical, and the shampoo aisle was never built to treat it.</a:t>
             </a:r>
@@ -4067,7 +4067,7 @@
                 <a:solidFill>
                   <a:srgbClr val="641220"/>
                 </a:solidFill>
-                <a:latin typeface="Montserrat"/>
+                <a:latin typeface="ABC Maxi Sharp"/>
               </a:rPr>
               <a:t>04 / 08</a:t>
             </a:r>
@@ -4106,7 +4106,7 @@
                 <a:solidFill>
                   <a:srgbClr val="C54427"/>
                 </a:solidFill>
-                <a:latin typeface="Montserrat"/>
+                <a:latin typeface="ABC Maxi Sharp"/>
               </a:rPr>
               <a:t>THE WAIT</a:t>
             </a:r>
@@ -4145,7 +4145,7 @@
                 <a:solidFill>
                   <a:srgbClr val="641220"/>
                 </a:solidFill>
-                <a:latin typeface="Georgia"/>
+                <a:latin typeface="STK Bureau Serif Light"/>
               </a:rPr>
               <a:t>3.6</a:t>
             </a:r>
@@ -4184,7 +4184,7 @@
                 <a:solidFill>
                   <a:srgbClr val="C54427"/>
                 </a:solidFill>
-                <a:latin typeface="Georgia"/>
+                <a:latin typeface="STK Bureau Serif Light"/>
               </a:rPr>
               <a:t>years</a:t>
             </a:r>
@@ -4223,7 +4223,7 @@
                 <a:solidFill>
                   <a:srgbClr val="2A0208"/>
                 </a:solidFill>
-                <a:latin typeface="Open Sans"/>
+                <a:latin typeface="STK Bureau Sans Book"/>
               </a:rPr>
               <a:t>The average time spent chasing a wrong diagnosis for a chronic skin condition. Flaking gets written off as dryness or product buildup while the actual cause goes untreated.</a:t>
             </a:r>
@@ -4312,7 +4312,7 @@
                 <a:solidFill>
                   <a:srgbClr val="C5FEFF"/>
                 </a:solidFill>
-                <a:latin typeface="Montserrat"/>
+                <a:latin typeface="ABC Maxi Sharp"/>
               </a:rPr>
               <a:t>05 / 08</a:t>
             </a:r>
@@ -4351,7 +4351,7 @@
                 <a:solidFill>
                   <a:srgbClr val="C5FEFF"/>
                 </a:solidFill>
-                <a:latin typeface="Montserrat"/>
+                <a:latin typeface="ABC Maxi Sharp"/>
               </a:rPr>
               <a:t>THE DIFFERENCE</a:t>
             </a:r>
@@ -4390,7 +4390,7 @@
                 <a:solidFill>
                   <a:srgbClr val="FFF4CE"/>
                 </a:solidFill>
-                <a:latin typeface="Georgia"/>
+                <a:latin typeface="STK Bureau Serif Light"/>
               </a:rPr>
               <a:t>Washing flakes away isn't the same as treating them</a:t>
             </a:r>
@@ -4475,7 +4475,7 @@
                 <a:solidFill>
                   <a:srgbClr val="C54427"/>
                 </a:solidFill>
-                <a:latin typeface="Montserrat"/>
+                <a:latin typeface="ABC Maxi Sharp"/>
               </a:rPr>
               <a:t>THE SHAMPOO AISLE</a:t>
             </a:r>
@@ -4514,7 +4514,7 @@
                 <a:solidFill>
                   <a:srgbClr val="2A0208"/>
                 </a:solidFill>
-                <a:latin typeface="Open Sans"/>
+                <a:latin typeface="STK Bureau Sans Book"/>
               </a:rPr>
               <a:t>Lifts flakes off the surface. The yeast underneath stays.</a:t>
             </a:r>
@@ -4599,7 +4599,7 @@
                 <a:solidFill>
                   <a:srgbClr val="F8B044"/>
                 </a:solidFill>
-                <a:latin typeface="Montserrat"/>
+                <a:latin typeface="ABC Maxi Sharp"/>
               </a:rPr>
               <a:t>PRESCRIPTION CARE</a:t>
             </a:r>
@@ -4638,7 +4638,7 @@
                 <a:solidFill>
                   <a:srgbClr val="FFF4CE"/>
                 </a:solidFill>
-                <a:latin typeface="Open Sans"/>
+                <a:latin typeface="STK Bureau Sans Book"/>
               </a:rPr>
               <a:t>Targets the yeast and calms the inflammation it triggers.</a:t>
             </a:r>
@@ -4768,7 +4768,7 @@
                 <a:solidFill>
                   <a:srgbClr val="FFF4CE"/>
                 </a:solidFill>
-                <a:latin typeface="Montserrat"/>
+                <a:latin typeface="ABC Maxi Sharp"/>
               </a:rPr>
               <a:t>06 / 08</a:t>
             </a:r>
@@ -4853,7 +4853,7 @@
                 <a:solidFill>
                   <a:srgbClr val="C54427"/>
                 </a:solidFill>
-                <a:latin typeface="Montserrat"/>
+                <a:latin typeface="ABC Maxi Sharp"/>
               </a:rPr>
               <a:t>OFTEN MISSED</a:t>
             </a:r>
@@ -4892,7 +4892,7 @@
                 <a:solidFill>
                   <a:srgbClr val="2A0208"/>
                 </a:solidFill>
-                <a:latin typeface="Georgia"/>
+                <a:latin typeface="STK Bureau Serif Light"/>
               </a:rPr>
               <a:t>On darker skin, it rarely looks like the textbook photos</a:t>
             </a:r>
@@ -4931,7 +4931,7 @@
                 <a:solidFill>
                   <a:srgbClr val="2A0208"/>
                 </a:solidFill>
-                <a:latin typeface="Open Sans"/>
+                <a:latin typeface="STK Bureau Sans Book"/>
               </a:rPr>
               <a:t>Flaking can show up as lighter patches, ring-shaped spots, or irritation along the hairline. On deeper skin tones these signs get misread more often. Care should know what to look for.</a:t>
             </a:r>
@@ -5020,7 +5020,7 @@
                 <a:solidFill>
                   <a:srgbClr val="F8B044"/>
                 </a:solidFill>
-                <a:latin typeface="Montserrat"/>
+                <a:latin typeface="ABC Maxi Sharp"/>
               </a:rPr>
               <a:t>SAVE THIS</a:t>
             </a:r>
@@ -5059,7 +5059,7 @@
                 <a:solidFill>
                   <a:srgbClr val="FFF4CE"/>
                 </a:solidFill>
-                <a:latin typeface="Georgia"/>
+                <a:latin typeface="STK Bureau Serif Light"/>
               </a:rPr>
               <a:t>The short version</a:t>
             </a:r>
@@ -5142,7 +5142,7 @@
                 <a:solidFill>
                   <a:srgbClr val="D4952A"/>
                 </a:solidFill>
-                <a:latin typeface="Montserrat"/>
+                <a:latin typeface="ABC Maxi Sharp"/>
               </a:rPr>
               <a:t>1</a:t>
             </a:r>
@@ -5181,7 +5181,7 @@
                 <a:solidFill>
                   <a:srgbClr val="FFF4CE"/>
                 </a:solidFill>
-                <a:latin typeface="Open Sans"/>
+                <a:latin typeface="STK Bureau Sans Book"/>
               </a:rPr>
               <a:t>Flakes that keep coming back are usually a yeast reaction, not dryness.</a:t>
             </a:r>
@@ -5264,7 +5264,7 @@
                 <a:solidFill>
                   <a:srgbClr val="D4952A"/>
                 </a:solidFill>
-                <a:latin typeface="Montserrat"/>
+                <a:latin typeface="ABC Maxi Sharp"/>
               </a:rPr>
               <a:t>2</a:t>
             </a:r>
@@ -5303,7 +5303,7 @@
                 <a:solidFill>
                   <a:srgbClr val="FFF4CE"/>
                 </a:solidFill>
-                <a:latin typeface="Open Sans"/>
+                <a:latin typeface="STK Bureau Sans Book"/>
               </a:rPr>
               <a:t>Shampoo manages the symptom. Treatment addresses the cause.</a:t>
             </a:r>
@@ -5386,7 +5386,7 @@
                 <a:solidFill>
                   <a:srgbClr val="D4952A"/>
                 </a:solidFill>
-                <a:latin typeface="Montserrat"/>
+                <a:latin typeface="ABC Maxi Sharp"/>
               </a:rPr>
               <a:t>3</a:t>
             </a:r>
@@ -5425,7 +5425,7 @@
                 <a:solidFill>
                   <a:srgbClr val="FFF4CE"/>
                 </a:solidFill>
-                <a:latin typeface="Open Sans"/>
+                <a:latin typeface="STK Bureau Sans Book"/>
               </a:rPr>
               <a:t>Darker skin shows different signs, and they get missed more often.</a:t>
             </a:r>
@@ -5508,7 +5508,7 @@
                 <a:solidFill>
                   <a:srgbClr val="D4952A"/>
                 </a:solidFill>
-                <a:latin typeface="Montserrat"/>
+                <a:latin typeface="ABC Maxi Sharp"/>
               </a:rPr>
               <a:t>4</a:t>
             </a:r>
@@ -5547,7 +5547,7 @@
                 <a:solidFill>
                   <a:srgbClr val="FFF4CE"/>
                 </a:solidFill>
-                <a:latin typeface="Open Sans"/>
+                <a:latin typeface="STK Bureau Sans Book"/>
               </a:rPr>
               <a:t>A provider can tell the difference from clear photos and history.</a:t>
             </a:r>
@@ -5610,7 +5610,7 @@
                 <a:solidFill>
                   <a:srgbClr val="D0B09A"/>
                 </a:solidFill>
-                <a:latin typeface="Montserrat"/>
+                <a:latin typeface="ABC Maxi Sharp"/>
               </a:rPr>
               <a:t>07 / 08</a:t>
             </a:r>
@@ -5715,7 +5715,7 @@
                 <a:solidFill>
                   <a:srgbClr val="FFF4CE"/>
                 </a:solidFill>
-                <a:latin typeface="Montserrat"/>
+                <a:latin typeface="ABC Maxi Sharp"/>
               </a:rPr>
               <a:t>08 / 08</a:t>
             </a:r>
@@ -5754,7 +5754,7 @@
                 <a:solidFill>
                   <a:srgbClr val="C54427"/>
                 </a:solidFill>
-                <a:latin typeface="Montserrat"/>
+                <a:latin typeface="ABC Maxi Sharp"/>
               </a:rPr>
               <a:t>START HERE</a:t>
             </a:r>
@@ -5793,7 +5793,7 @@
                 <a:solidFill>
                   <a:srgbClr val="2A0208"/>
                 </a:solidFill>
-                <a:latin typeface="Georgia"/>
+                <a:latin typeface="STK Bureau Serif Light"/>
               </a:rPr>
               <a:t>Scalp care, reviewed by a licensed provider</a:t>
             </a:r>
@@ -5832,7 +5832,7 @@
                 <a:solidFill>
                   <a:srgbClr val="2A0208"/>
                 </a:solidFill>
-                <a:latin typeface="Open Sans"/>
+                <a:latin typeface="STK Bureau Sans Book"/>
               </a:rPr>
               <a:t>Kyn Skyn connects patients with licensed providers who review photos and history online, then build a treatment plan. No waiting room.</a:t>
             </a:r>
@@ -5941,7 +5941,7 @@
                 <a:solidFill>
                   <a:srgbClr val="D4952A"/>
                 </a:solidFill>
-                <a:latin typeface="Montserrat"/>
+                <a:latin typeface="ABC Maxi Sharp"/>
               </a:rPr>
               <a:t>MONTHLY CARE PLAN</a:t>
             </a:r>
@@ -5980,7 +5980,7 @@
                 <a:solidFill>
                   <a:srgbClr val="F8B044"/>
                 </a:solidFill>
-                <a:latin typeface="Georgia"/>
+                <a:latin typeface="STK Bureau Serif Light"/>
               </a:rPr>
               <a:t>$29.99</a:t>
             </a:r>
@@ -6019,7 +6019,7 @@
                 <a:solidFill>
                   <a:srgbClr val="FFF4CE"/>
                 </a:solidFill>
-                <a:latin typeface="Open Sans"/>
+                <a:latin typeface="STK Bureau Sans Book"/>
               </a:rPr>
               <a:t>/ month</a:t>
             </a:r>
@@ -6058,7 +6058,7 @@
                 <a:solidFill>
                   <a:srgbClr val="F2E2C0"/>
                 </a:solidFill>
-                <a:latin typeface="Open Sans"/>
+                <a:latin typeface="STK Bureau Sans Book"/>
               </a:rPr>
               <a:t>Provider review and treatment plan included. Check‑ins after.</a:t>
             </a:r>
@@ -6113,7 +6113,7 @@
                 <a:solidFill>
                   <a:srgbClr val="2A0208"/>
                 </a:solidFill>
-                <a:latin typeface="Open Sans"/>
+                <a:latin typeface="STK Bureau Sans Book"/>
               </a:rPr>
               <a:t>Get a Kynsultation</a:t>
             </a:r>
@@ -6152,7 +6152,7 @@
                 <a:solidFill>
                   <a:srgbClr val="D4952A"/>
                 </a:solidFill>
-                <a:latin typeface="Open Sans"/>
+                <a:latin typeface="STK Bureau Sans Book"/>
               </a:rPr>
               <a:t>kynskyn.com</a:t>
             </a:r>

</xml_diff>